<commit_message>
PPT: auto-play embedded Claude videos on slide entry + fade transitions
</commit_message>
<xml_diff>
--- a/AGENTIC-PM-workspaces-video.pptx
+++ b/AGENTIC-PM-workspaces-video.pptx
@@ -3119,6 +3119,9 @@
   <p:clrMapOvr>
     <a:masterClrMapping/>
   </p:clrMapOvr>
+  <p:transition spd="med">
+    <p:fade/>
+  </p:transition>
 </p:sld>
 </file>
 
@@ -3194,14 +3197,72 @@
   <p:clrMapOvr>
     <a:masterClrMapping/>
   </p:clrMapOvr>
+  <p:transition spd="med">
+    <p:fade/>
+  </p:transition>
   <p:timing>
     <p:tnLst>
       <p:par>
         <p:cTn id="1" dur="indefinite" restart="never" nodeType="tmRoot">
           <p:childTnLst>
+            <p:seq concurrent="1" nextAc="seek">
+              <p:cTn id="2" dur="indefinite" nodeType="mainSeq">
+                <p:childTnLst>
+                  <p:par>
+                    <p:cTn id="3" fill="hold">
+                      <p:stCondLst>
+                        <p:cond delay="0"/>
+                      </p:stCondLst>
+                      <p:childTnLst>
+                        <p:par>
+                          <p:cTn id="4" fill="hold">
+                            <p:stCondLst>
+                              <p:cond delay="0"/>
+                            </p:stCondLst>
+                            <p:childTnLst>
+                              <p:par>
+                                <p:cTn id="5" presetID="1" presetClass="mediacall" presetSubtype="0" fill="hold" nodeType="afterEffect">
+                                  <p:stCondLst>
+                                    <p:cond delay="0"/>
+                                  </p:stCondLst>
+                                  <p:childTnLst>
+                                    <p:cmd type="call" cmd="playFrom(0.0)">
+                                      <p:cBhvr>
+                                        <p:cTn id="6" dur="13560" fill="hold"/>
+                                        <p:tgtEl>
+                                          <p:spTgt spid="3"/>
+                                        </p:tgtEl>
+                                      </p:cBhvr>
+                                    </p:cmd>
+                                  </p:childTnLst>
+                                </p:cTn>
+                              </p:par>
+                            </p:childTnLst>
+                          </p:cTn>
+                        </p:par>
+                      </p:childTnLst>
+                    </p:cTn>
+                  </p:par>
+                </p:childTnLst>
+              </p:cTn>
+              <p:prevCondLst>
+                <p:cond evt="onPrev" delay="0">
+                  <p:tgtEl>
+                    <p:sldTgt/>
+                  </p:tgtEl>
+                </p:cond>
+              </p:prevCondLst>
+              <p:nextCondLst>
+                <p:cond evt="onNext" delay="0">
+                  <p:tgtEl>
+                    <p:sldTgt/>
+                  </p:tgtEl>
+                </p:cond>
+              </p:nextCondLst>
+            </p:seq>
             <p:video>
               <p:cMediaNode vol="80000">
-                <p:cTn id="2" fill="hold" display="0">
+                <p:cTn id="7" fill="hold" display="0">
                   <p:stCondLst>
                     <p:cond delay="indefinite"/>
                   </p:stCondLst>
@@ -3291,14 +3352,72 @@
   <p:clrMapOvr>
     <a:masterClrMapping/>
   </p:clrMapOvr>
+  <p:transition spd="med">
+    <p:fade/>
+  </p:transition>
   <p:timing>
     <p:tnLst>
       <p:par>
         <p:cTn id="1" dur="indefinite" restart="never" nodeType="tmRoot">
           <p:childTnLst>
+            <p:seq concurrent="1" nextAc="seek">
+              <p:cTn id="2" dur="indefinite" nodeType="mainSeq">
+                <p:childTnLst>
+                  <p:par>
+                    <p:cTn id="3" fill="hold">
+                      <p:stCondLst>
+                        <p:cond delay="0"/>
+                      </p:stCondLst>
+                      <p:childTnLst>
+                        <p:par>
+                          <p:cTn id="4" fill="hold">
+                            <p:stCondLst>
+                              <p:cond delay="0"/>
+                            </p:stCondLst>
+                            <p:childTnLst>
+                              <p:par>
+                                <p:cTn id="5" presetID="1" presetClass="mediacall" presetSubtype="0" fill="hold" nodeType="afterEffect">
+                                  <p:stCondLst>
+                                    <p:cond delay="0"/>
+                                  </p:stCondLst>
+                                  <p:childTnLst>
+                                    <p:cmd type="call" cmd="playFrom(0.0)">
+                                      <p:cBhvr>
+                                        <p:cTn id="6" dur="14120" fill="hold"/>
+                                        <p:tgtEl>
+                                          <p:spTgt spid="3"/>
+                                        </p:tgtEl>
+                                      </p:cBhvr>
+                                    </p:cmd>
+                                  </p:childTnLst>
+                                </p:cTn>
+                              </p:par>
+                            </p:childTnLst>
+                          </p:cTn>
+                        </p:par>
+                      </p:childTnLst>
+                    </p:cTn>
+                  </p:par>
+                </p:childTnLst>
+              </p:cTn>
+              <p:prevCondLst>
+                <p:cond evt="onPrev" delay="0">
+                  <p:tgtEl>
+                    <p:sldTgt/>
+                  </p:tgtEl>
+                </p:cond>
+              </p:prevCondLst>
+              <p:nextCondLst>
+                <p:cond evt="onNext" delay="0">
+                  <p:tgtEl>
+                    <p:sldTgt/>
+                  </p:tgtEl>
+                </p:cond>
+              </p:nextCondLst>
+            </p:seq>
             <p:video>
               <p:cMediaNode vol="80000">
-                <p:cTn id="2" fill="hold" display="0">
+                <p:cTn id="7" fill="hold" display="0">
                   <p:stCondLst>
                     <p:cond delay="indefinite"/>
                   </p:stCondLst>

</xml_diff>

<commit_message>
PPT: staggered object fade-in animations on slide 1 (auto on entry)
</commit_message>
<xml_diff>
--- a/AGENTIC-PM-workspaces-video.pptx
+++ b/AGENTIC-PM-workspaces-video.pptx
@@ -3092,7 +3092,7 @@
       <p:grpSpPr/>
       <p:pic>
         <p:nvPicPr>
-          <p:cNvPr id="2" name="Picture 1" descr="w2-1.png"/>
+          <p:cNvPr id="2" name="Picture 1" descr="s1-bg.png"/>
           <p:cNvPicPr>
             <a:picLocks noChangeAspect="1"/>
           </p:cNvPicPr>
@@ -3114,6 +3114,198 @@
           </a:prstGeom>
         </p:spPr>
       </p:pic>
+      <p:pic>
+        <p:nvPicPr>
+          <p:cNvPr id="3" name="Picture 2" descr="obj-brand.png"/>
+          <p:cNvPicPr>
+            <a:picLocks noChangeAspect="1"/>
+          </p:cNvPicPr>
+          <p:nvPr/>
+        </p:nvPicPr>
+        <p:blipFill>
+          <a:blip r:embed="rId3"/>
+          <a:stretch>
+            <a:fillRect/>
+          </a:stretch>
+        </p:blipFill>
+        <p:spPr>
+          <a:xfrm>
+            <a:off x="10413045" y="419089"/>
+            <a:ext cx="1245263" cy="266693"/>
+          </a:xfrm>
+          <a:prstGeom prst="rect">
+            <a:avLst/>
+          </a:prstGeom>
+        </p:spPr>
+      </p:pic>
+      <p:pic>
+        <p:nvPicPr>
+          <p:cNvPr id="4" name="Picture 3" descr="obj-eyebrow.png"/>
+          <p:cNvPicPr>
+            <a:picLocks noChangeAspect="1"/>
+          </p:cNvPicPr>
+          <p:nvPr/>
+        </p:nvPicPr>
+        <p:blipFill>
+          <a:blip r:embed="rId4"/>
+          <a:stretch>
+            <a:fillRect/>
+          </a:stretch>
+        </p:blipFill>
+        <p:spPr>
+          <a:xfrm>
+            <a:off x="5411156" y="1463043"/>
+            <a:ext cx="1369382" cy="101597"/>
+          </a:xfrm>
+          <a:prstGeom prst="rect">
+            <a:avLst/>
+          </a:prstGeom>
+        </p:spPr>
+      </p:pic>
+      <p:pic>
+        <p:nvPicPr>
+          <p:cNvPr id="5" name="Picture 4" descr="obj-title.png"/>
+          <p:cNvPicPr>
+            <a:picLocks noChangeAspect="1"/>
+          </p:cNvPicPr>
+          <p:nvPr/>
+        </p:nvPicPr>
+        <p:blipFill>
+          <a:blip r:embed="rId5"/>
+          <a:stretch>
+            <a:fillRect/>
+          </a:stretch>
+        </p:blipFill>
+        <p:spPr>
+          <a:xfrm>
+            <a:off x="2113901" y="1678937"/>
+            <a:ext cx="7963792" cy="558786"/>
+          </a:xfrm>
+          <a:prstGeom prst="rect">
+            <a:avLst/>
+          </a:prstGeom>
+        </p:spPr>
+      </p:pic>
+      <p:pic>
+        <p:nvPicPr>
+          <p:cNvPr id="6" name="Picture 5" descr="obj-sub.png"/>
+          <p:cNvPicPr>
+            <a:picLocks noChangeAspect="1"/>
+          </p:cNvPicPr>
+          <p:nvPr/>
+        </p:nvPicPr>
+        <p:blipFill>
+          <a:blip r:embed="rId6"/>
+          <a:stretch>
+            <a:fillRect/>
+          </a:stretch>
+        </p:blipFill>
+        <p:spPr>
+          <a:xfrm>
+            <a:off x="3358966" y="2390119"/>
+            <a:ext cx="5473761" cy="368290"/>
+          </a:xfrm>
+          <a:prstGeom prst="rect">
+            <a:avLst/>
+          </a:prstGeom>
+        </p:spPr>
+      </p:pic>
+      <p:pic>
+        <p:nvPicPr>
+          <p:cNvPr id="7" name="Picture 6" descr="obj-split.png"/>
+          <p:cNvPicPr>
+            <a:picLocks noChangeAspect="1"/>
+          </p:cNvPicPr>
+          <p:nvPr/>
+        </p:nvPicPr>
+        <p:blipFill>
+          <a:blip r:embed="rId7"/>
+          <a:stretch>
+            <a:fillRect/>
+          </a:stretch>
+        </p:blipFill>
+        <p:spPr>
+          <a:xfrm>
+            <a:off x="5381093" y="3063203"/>
+            <a:ext cx="1429508" cy="95247"/>
+          </a:xfrm>
+          <a:prstGeom prst="rect">
+            <a:avLst/>
+          </a:prstGeom>
+        </p:spPr>
+      </p:pic>
+      <p:pic>
+        <p:nvPicPr>
+          <p:cNvPr id="8" name="Picture 7" descr="obj-cardA.png"/>
+          <p:cNvPicPr>
+            <a:picLocks noChangeAspect="1"/>
+          </p:cNvPicPr>
+          <p:nvPr/>
+        </p:nvPicPr>
+        <p:blipFill>
+          <a:blip r:embed="rId8"/>
+          <a:stretch>
+            <a:fillRect/>
+          </a:stretch>
+        </p:blipFill>
+        <p:spPr>
+          <a:xfrm>
+            <a:off x="2825679" y="3285447"/>
+            <a:ext cx="3174920" cy="1702948"/>
+          </a:xfrm>
+          <a:prstGeom prst="rect">
+            <a:avLst/>
+          </a:prstGeom>
+        </p:spPr>
+      </p:pic>
+      <p:pic>
+        <p:nvPicPr>
+          <p:cNvPr id="9" name="Picture 8" descr="obj-cardB.png"/>
+          <p:cNvPicPr>
+            <a:picLocks noChangeAspect="1"/>
+          </p:cNvPicPr>
+          <p:nvPr/>
+        </p:nvPicPr>
+        <p:blipFill>
+          <a:blip r:embed="rId9"/>
+          <a:stretch>
+            <a:fillRect/>
+          </a:stretch>
+        </p:blipFill>
+        <p:spPr>
+          <a:xfrm>
+            <a:off x="6191095" y="3285447"/>
+            <a:ext cx="3174920" cy="1702948"/>
+          </a:xfrm>
+          <a:prstGeom prst="rect">
+            <a:avLst/>
+          </a:prstGeom>
+        </p:spPr>
+      </p:pic>
+      <p:pic>
+        <p:nvPicPr>
+          <p:cNvPr id="10" name="Picture 9" descr="obj-foot.png"/>
+          <p:cNvPicPr>
+            <a:picLocks noChangeAspect="1"/>
+          </p:cNvPicPr>
+          <p:nvPr/>
+        </p:nvPicPr>
+        <p:blipFill>
+          <a:blip r:embed="rId10"/>
+          <a:stretch>
+            <a:fillRect/>
+          </a:stretch>
+        </p:blipFill>
+        <p:spPr>
+          <a:xfrm>
+            <a:off x="4517515" y="5242389"/>
+            <a:ext cx="3156664" cy="152396"/>
+          </a:xfrm>
+          <a:prstGeom prst="rect">
+            <a:avLst/>
+          </a:prstGeom>
+        </p:spPr>
+      </p:pic>
     </p:spTree>
   </p:cSld>
   <p:clrMapOvr>
@@ -3122,6 +3314,388 @@
   <p:transition spd="med">
     <p:fade/>
   </p:transition>
+  <p:timing>
+    <p:tnLst>
+      <p:par>
+        <p:cTn id="1" dur="indefinite" restart="never" nodeType="tmRoot">
+          <p:childTnLst>
+            <p:seq concurrent="1" nextAc="seek">
+              <p:cTn id="2" dur="indefinite" nodeType="mainSeq">
+                <p:childTnLst>
+                  <p:par>
+                    <p:cTn id="3" fill="hold" nodeType="withEffect">
+                      <p:stCondLst>
+                        <p:cond delay="0"/>
+                      </p:stCondLst>
+                      <p:childTnLst>
+                        <p:par>
+                          <p:cTn id="4" presetID="10" presetClass="entr" presetSubtype="0" fill="hold" grpId="0" nodeType="withEffect">
+                            <p:stCondLst>
+                              <p:cond delay="0"/>
+                            </p:stCondLst>
+                            <p:childTnLst>
+                              <p:set>
+                                <p:cBhvr>
+                                  <p:cTn id="5" dur="1" fill="hold">
+                                    <p:stCondLst>
+                                      <p:cond delay="0"/>
+                                    </p:stCondLst>
+                                  </p:cTn>
+                                  <p:tgtEl>
+                                    <p:spTgt spid="3"/>
+                                  </p:tgtEl>
+                                  <p:attrNameLst>
+                                    <p:attrName>style.visibility</p:attrName>
+                                  </p:attrNameLst>
+                                </p:cBhvr>
+                                <p:to>
+                                  <p:strVal val="visible"/>
+                                </p:to>
+                              </p:set>
+                              <p:animEffect transition="in" filter="fade">
+                                <p:cBhvr>
+                                  <p:cTn id="6" dur="450"/>
+                                  <p:tgtEl>
+                                    <p:spTgt spid="3"/>
+                                  </p:tgtEl>
+                                </p:cBhvr>
+                              </p:animEffect>
+                            </p:childTnLst>
+                          </p:cTn>
+                        </p:par>
+                      </p:childTnLst>
+                    </p:cTn>
+                  </p:par>
+                  <p:par>
+                    <p:cTn id="7" fill="hold" nodeType="afterEffect">
+                      <p:stCondLst>
+                        <p:cond delay="0"/>
+                      </p:stCondLst>
+                      <p:childTnLst>
+                        <p:par>
+                          <p:cTn id="8" presetID="10" presetClass="entr" presetSubtype="0" fill="hold" grpId="0" nodeType="withEffect">
+                            <p:stCondLst>
+                              <p:cond delay="0"/>
+                            </p:stCondLst>
+                            <p:childTnLst>
+                              <p:set>
+                                <p:cBhvr>
+                                  <p:cTn id="9" dur="1" fill="hold">
+                                    <p:stCondLst>
+                                      <p:cond delay="0"/>
+                                    </p:stCondLst>
+                                  </p:cTn>
+                                  <p:tgtEl>
+                                    <p:spTgt spid="4"/>
+                                  </p:tgtEl>
+                                  <p:attrNameLst>
+                                    <p:attrName>style.visibility</p:attrName>
+                                  </p:attrNameLst>
+                                </p:cBhvr>
+                                <p:to>
+                                  <p:strVal val="visible"/>
+                                </p:to>
+                              </p:set>
+                              <p:animEffect transition="in" filter="fade">
+                                <p:cBhvr>
+                                  <p:cTn id="10" dur="450"/>
+                                  <p:tgtEl>
+                                    <p:spTgt spid="4"/>
+                                  </p:tgtEl>
+                                </p:cBhvr>
+                              </p:animEffect>
+                            </p:childTnLst>
+                          </p:cTn>
+                        </p:par>
+                      </p:childTnLst>
+                    </p:cTn>
+                  </p:par>
+                  <p:par>
+                    <p:cTn id="11" fill="hold" nodeType="afterEffect">
+                      <p:stCondLst>
+                        <p:cond delay="0"/>
+                      </p:stCondLst>
+                      <p:childTnLst>
+                        <p:par>
+                          <p:cTn id="12" presetID="10" presetClass="entr" presetSubtype="0" fill="hold" grpId="0" nodeType="withEffect">
+                            <p:stCondLst>
+                              <p:cond delay="0"/>
+                            </p:stCondLst>
+                            <p:childTnLst>
+                              <p:set>
+                                <p:cBhvr>
+                                  <p:cTn id="13" dur="1" fill="hold">
+                                    <p:stCondLst>
+                                      <p:cond delay="0"/>
+                                    </p:stCondLst>
+                                  </p:cTn>
+                                  <p:tgtEl>
+                                    <p:spTgt spid="5"/>
+                                  </p:tgtEl>
+                                  <p:attrNameLst>
+                                    <p:attrName>style.visibility</p:attrName>
+                                  </p:attrNameLst>
+                                </p:cBhvr>
+                                <p:to>
+                                  <p:strVal val="visible"/>
+                                </p:to>
+                              </p:set>
+                              <p:animEffect transition="in" filter="fade">
+                                <p:cBhvr>
+                                  <p:cTn id="14" dur="450"/>
+                                  <p:tgtEl>
+                                    <p:spTgt spid="5"/>
+                                  </p:tgtEl>
+                                </p:cBhvr>
+                              </p:animEffect>
+                            </p:childTnLst>
+                          </p:cTn>
+                        </p:par>
+                      </p:childTnLst>
+                    </p:cTn>
+                  </p:par>
+                  <p:par>
+                    <p:cTn id="15" fill="hold" nodeType="afterEffect">
+                      <p:stCondLst>
+                        <p:cond delay="0"/>
+                      </p:stCondLst>
+                      <p:childTnLst>
+                        <p:par>
+                          <p:cTn id="16" presetID="10" presetClass="entr" presetSubtype="0" fill="hold" grpId="0" nodeType="withEffect">
+                            <p:stCondLst>
+                              <p:cond delay="0"/>
+                            </p:stCondLst>
+                            <p:childTnLst>
+                              <p:set>
+                                <p:cBhvr>
+                                  <p:cTn id="17" dur="1" fill="hold">
+                                    <p:stCondLst>
+                                      <p:cond delay="0"/>
+                                    </p:stCondLst>
+                                  </p:cTn>
+                                  <p:tgtEl>
+                                    <p:spTgt spid="6"/>
+                                  </p:tgtEl>
+                                  <p:attrNameLst>
+                                    <p:attrName>style.visibility</p:attrName>
+                                  </p:attrNameLst>
+                                </p:cBhvr>
+                                <p:to>
+                                  <p:strVal val="visible"/>
+                                </p:to>
+                              </p:set>
+                              <p:animEffect transition="in" filter="fade">
+                                <p:cBhvr>
+                                  <p:cTn id="18" dur="450"/>
+                                  <p:tgtEl>
+                                    <p:spTgt spid="6"/>
+                                  </p:tgtEl>
+                                </p:cBhvr>
+                              </p:animEffect>
+                            </p:childTnLst>
+                          </p:cTn>
+                        </p:par>
+                      </p:childTnLst>
+                    </p:cTn>
+                  </p:par>
+                  <p:par>
+                    <p:cTn id="19" fill="hold" nodeType="afterEffect">
+                      <p:stCondLst>
+                        <p:cond delay="0"/>
+                      </p:stCondLst>
+                      <p:childTnLst>
+                        <p:par>
+                          <p:cTn id="20" presetID="10" presetClass="entr" presetSubtype="0" fill="hold" grpId="0" nodeType="withEffect">
+                            <p:stCondLst>
+                              <p:cond delay="0"/>
+                            </p:stCondLst>
+                            <p:childTnLst>
+                              <p:set>
+                                <p:cBhvr>
+                                  <p:cTn id="21" dur="1" fill="hold">
+                                    <p:stCondLst>
+                                      <p:cond delay="0"/>
+                                    </p:stCondLst>
+                                  </p:cTn>
+                                  <p:tgtEl>
+                                    <p:spTgt spid="7"/>
+                                  </p:tgtEl>
+                                  <p:attrNameLst>
+                                    <p:attrName>style.visibility</p:attrName>
+                                  </p:attrNameLst>
+                                </p:cBhvr>
+                                <p:to>
+                                  <p:strVal val="visible"/>
+                                </p:to>
+                              </p:set>
+                              <p:animEffect transition="in" filter="fade">
+                                <p:cBhvr>
+                                  <p:cTn id="22" dur="450"/>
+                                  <p:tgtEl>
+                                    <p:spTgt spid="7"/>
+                                  </p:tgtEl>
+                                </p:cBhvr>
+                              </p:animEffect>
+                            </p:childTnLst>
+                          </p:cTn>
+                        </p:par>
+                      </p:childTnLst>
+                    </p:cTn>
+                  </p:par>
+                  <p:par>
+                    <p:cTn id="23" fill="hold" nodeType="afterEffect">
+                      <p:stCondLst>
+                        <p:cond delay="0"/>
+                      </p:stCondLst>
+                      <p:childTnLst>
+                        <p:par>
+                          <p:cTn id="24" presetID="10" presetClass="entr" presetSubtype="0" fill="hold" grpId="0" nodeType="withEffect">
+                            <p:stCondLst>
+                              <p:cond delay="0"/>
+                            </p:stCondLst>
+                            <p:childTnLst>
+                              <p:set>
+                                <p:cBhvr>
+                                  <p:cTn id="25" dur="1" fill="hold">
+                                    <p:stCondLst>
+                                      <p:cond delay="0"/>
+                                    </p:stCondLst>
+                                  </p:cTn>
+                                  <p:tgtEl>
+                                    <p:spTgt spid="8"/>
+                                  </p:tgtEl>
+                                  <p:attrNameLst>
+                                    <p:attrName>style.visibility</p:attrName>
+                                  </p:attrNameLst>
+                                </p:cBhvr>
+                                <p:to>
+                                  <p:strVal val="visible"/>
+                                </p:to>
+                              </p:set>
+                              <p:animEffect transition="in" filter="fade">
+                                <p:cBhvr>
+                                  <p:cTn id="26" dur="450"/>
+                                  <p:tgtEl>
+                                    <p:spTgt spid="8"/>
+                                  </p:tgtEl>
+                                </p:cBhvr>
+                              </p:animEffect>
+                            </p:childTnLst>
+                          </p:cTn>
+                        </p:par>
+                      </p:childTnLst>
+                    </p:cTn>
+                  </p:par>
+                  <p:par>
+                    <p:cTn id="27" fill="hold" nodeType="afterEffect">
+                      <p:stCondLst>
+                        <p:cond delay="0"/>
+                      </p:stCondLst>
+                      <p:childTnLst>
+                        <p:par>
+                          <p:cTn id="28" presetID="10" presetClass="entr" presetSubtype="0" fill="hold" grpId="0" nodeType="withEffect">
+                            <p:stCondLst>
+                              <p:cond delay="0"/>
+                            </p:stCondLst>
+                            <p:childTnLst>
+                              <p:set>
+                                <p:cBhvr>
+                                  <p:cTn id="29" dur="1" fill="hold">
+                                    <p:stCondLst>
+                                      <p:cond delay="0"/>
+                                    </p:stCondLst>
+                                  </p:cTn>
+                                  <p:tgtEl>
+                                    <p:spTgt spid="9"/>
+                                  </p:tgtEl>
+                                  <p:attrNameLst>
+                                    <p:attrName>style.visibility</p:attrName>
+                                  </p:attrNameLst>
+                                </p:cBhvr>
+                                <p:to>
+                                  <p:strVal val="visible"/>
+                                </p:to>
+                              </p:set>
+                              <p:animEffect transition="in" filter="fade">
+                                <p:cBhvr>
+                                  <p:cTn id="30" dur="450"/>
+                                  <p:tgtEl>
+                                    <p:spTgt spid="9"/>
+                                  </p:tgtEl>
+                                </p:cBhvr>
+                              </p:animEffect>
+                            </p:childTnLst>
+                          </p:cTn>
+                        </p:par>
+                      </p:childTnLst>
+                    </p:cTn>
+                  </p:par>
+                  <p:par>
+                    <p:cTn id="31" fill="hold" nodeType="afterEffect">
+                      <p:stCondLst>
+                        <p:cond delay="0"/>
+                      </p:stCondLst>
+                      <p:childTnLst>
+                        <p:par>
+                          <p:cTn id="32" presetID="10" presetClass="entr" presetSubtype="0" fill="hold" grpId="0" nodeType="withEffect">
+                            <p:stCondLst>
+                              <p:cond delay="0"/>
+                            </p:stCondLst>
+                            <p:childTnLst>
+                              <p:set>
+                                <p:cBhvr>
+                                  <p:cTn id="33" dur="1" fill="hold">
+                                    <p:stCondLst>
+                                      <p:cond delay="0"/>
+                                    </p:stCondLst>
+                                  </p:cTn>
+                                  <p:tgtEl>
+                                    <p:spTgt spid="10"/>
+                                  </p:tgtEl>
+                                  <p:attrNameLst>
+                                    <p:attrName>style.visibility</p:attrName>
+                                  </p:attrNameLst>
+                                </p:cBhvr>
+                                <p:to>
+                                  <p:strVal val="visible"/>
+                                </p:to>
+                              </p:set>
+                              <p:animEffect transition="in" filter="fade">
+                                <p:cBhvr>
+                                  <p:cTn id="34" dur="450"/>
+                                  <p:tgtEl>
+                                    <p:spTgt spid="10"/>
+                                  </p:tgtEl>
+                                </p:cBhvr>
+                              </p:animEffect>
+                            </p:childTnLst>
+                          </p:cTn>
+                        </p:par>
+                      </p:childTnLst>
+                    </p:cTn>
+                  </p:par>
+                </p:childTnLst>
+              </p:cTn>
+              <p:prevCondLst>
+                <p:cond evt="onPrev" delay="0">
+                  <p:tgtEl>
+                    <p:sldTgt/>
+                  </p:tgtEl>
+                </p:cond>
+              </p:prevCondLst>
+              <p:nextCondLst>
+                <p:cond evt="onNext" delay="0">
+                  <p:tgtEl>
+                    <p:sldTgt/>
+                  </p:tgtEl>
+                </p:cond>
+              </p:nextCondLst>
+            </p:seq>
+          </p:childTnLst>
+        </p:cTn>
+      </p:par>
+    </p:tnLst>
+  </p:timing>
 </p:sld>
 </file>
 

</xml_diff>

<commit_message>
Rework Claude UI demos: single APM Plugin with skill hover-submenu
- Plugin menu now shows one "APM Plugin" item; hovering reveals a
  submenu of skills (Company Profile, Company Screening, Market Research,
  CIM Screener, Comps, IC Memo) with the active skill highlighted.
- Chip in the composer now shows the selected skill name (e.g.
  "Market Research" / "CIM Screener") instead of the workspace name.
- Add combined Claude demo video (sourcing then diligence) and rebuild
  the 3-slide PPT with the new-UI embedded auto-play clips.

Co-Authored-By: Claude Opus 4.8 <noreply@anthropic.com>
Claude-Session: https://claude.ai/code/session_011YSka9wdq7KrBYzbQXMRhD
</commit_message>
<xml_diff>
--- a/AGENTIC-PM-workspaces-video.pptx
+++ b/AGENTIC-PM-workspaces-video.pptx
@@ -3311,391 +3311,6 @@
   <p:clrMapOvr>
     <a:masterClrMapping/>
   </p:clrMapOvr>
-  <p:transition spd="med">
-    <p:fade/>
-  </p:transition>
-  <p:timing>
-    <p:tnLst>
-      <p:par>
-        <p:cTn id="1" dur="indefinite" restart="never" nodeType="tmRoot">
-          <p:childTnLst>
-            <p:seq concurrent="1" nextAc="seek">
-              <p:cTn id="2" dur="indefinite" nodeType="mainSeq">
-                <p:childTnLst>
-                  <p:par>
-                    <p:cTn id="3" fill="hold" nodeType="withEffect">
-                      <p:stCondLst>
-                        <p:cond delay="0"/>
-                      </p:stCondLst>
-                      <p:childTnLst>
-                        <p:par>
-                          <p:cTn id="4" presetID="10" presetClass="entr" presetSubtype="0" fill="hold" grpId="0" nodeType="withEffect">
-                            <p:stCondLst>
-                              <p:cond delay="0"/>
-                            </p:stCondLst>
-                            <p:childTnLst>
-                              <p:set>
-                                <p:cBhvr>
-                                  <p:cTn id="5" dur="1" fill="hold">
-                                    <p:stCondLst>
-                                      <p:cond delay="0"/>
-                                    </p:stCondLst>
-                                  </p:cTn>
-                                  <p:tgtEl>
-                                    <p:spTgt spid="3"/>
-                                  </p:tgtEl>
-                                  <p:attrNameLst>
-                                    <p:attrName>style.visibility</p:attrName>
-                                  </p:attrNameLst>
-                                </p:cBhvr>
-                                <p:to>
-                                  <p:strVal val="visible"/>
-                                </p:to>
-                              </p:set>
-                              <p:animEffect transition="in" filter="fade">
-                                <p:cBhvr>
-                                  <p:cTn id="6" dur="450"/>
-                                  <p:tgtEl>
-                                    <p:spTgt spid="3"/>
-                                  </p:tgtEl>
-                                </p:cBhvr>
-                              </p:animEffect>
-                            </p:childTnLst>
-                          </p:cTn>
-                        </p:par>
-                      </p:childTnLst>
-                    </p:cTn>
-                  </p:par>
-                  <p:par>
-                    <p:cTn id="7" fill="hold" nodeType="afterEffect">
-                      <p:stCondLst>
-                        <p:cond delay="0"/>
-                      </p:stCondLst>
-                      <p:childTnLst>
-                        <p:par>
-                          <p:cTn id="8" presetID="10" presetClass="entr" presetSubtype="0" fill="hold" grpId="0" nodeType="withEffect">
-                            <p:stCondLst>
-                              <p:cond delay="0"/>
-                            </p:stCondLst>
-                            <p:childTnLst>
-                              <p:set>
-                                <p:cBhvr>
-                                  <p:cTn id="9" dur="1" fill="hold">
-                                    <p:stCondLst>
-                                      <p:cond delay="0"/>
-                                    </p:stCondLst>
-                                  </p:cTn>
-                                  <p:tgtEl>
-                                    <p:spTgt spid="4"/>
-                                  </p:tgtEl>
-                                  <p:attrNameLst>
-                                    <p:attrName>style.visibility</p:attrName>
-                                  </p:attrNameLst>
-                                </p:cBhvr>
-                                <p:to>
-                                  <p:strVal val="visible"/>
-                                </p:to>
-                              </p:set>
-                              <p:animEffect transition="in" filter="fade">
-                                <p:cBhvr>
-                                  <p:cTn id="10" dur="450"/>
-                                  <p:tgtEl>
-                                    <p:spTgt spid="4"/>
-                                  </p:tgtEl>
-                                </p:cBhvr>
-                              </p:animEffect>
-                            </p:childTnLst>
-                          </p:cTn>
-                        </p:par>
-                      </p:childTnLst>
-                    </p:cTn>
-                  </p:par>
-                  <p:par>
-                    <p:cTn id="11" fill="hold" nodeType="afterEffect">
-                      <p:stCondLst>
-                        <p:cond delay="0"/>
-                      </p:stCondLst>
-                      <p:childTnLst>
-                        <p:par>
-                          <p:cTn id="12" presetID="10" presetClass="entr" presetSubtype="0" fill="hold" grpId="0" nodeType="withEffect">
-                            <p:stCondLst>
-                              <p:cond delay="0"/>
-                            </p:stCondLst>
-                            <p:childTnLst>
-                              <p:set>
-                                <p:cBhvr>
-                                  <p:cTn id="13" dur="1" fill="hold">
-                                    <p:stCondLst>
-                                      <p:cond delay="0"/>
-                                    </p:stCondLst>
-                                  </p:cTn>
-                                  <p:tgtEl>
-                                    <p:spTgt spid="5"/>
-                                  </p:tgtEl>
-                                  <p:attrNameLst>
-                                    <p:attrName>style.visibility</p:attrName>
-                                  </p:attrNameLst>
-                                </p:cBhvr>
-                                <p:to>
-                                  <p:strVal val="visible"/>
-                                </p:to>
-                              </p:set>
-                              <p:animEffect transition="in" filter="fade">
-                                <p:cBhvr>
-                                  <p:cTn id="14" dur="450"/>
-                                  <p:tgtEl>
-                                    <p:spTgt spid="5"/>
-                                  </p:tgtEl>
-                                </p:cBhvr>
-                              </p:animEffect>
-                            </p:childTnLst>
-                          </p:cTn>
-                        </p:par>
-                      </p:childTnLst>
-                    </p:cTn>
-                  </p:par>
-                  <p:par>
-                    <p:cTn id="15" fill="hold" nodeType="afterEffect">
-                      <p:stCondLst>
-                        <p:cond delay="0"/>
-                      </p:stCondLst>
-                      <p:childTnLst>
-                        <p:par>
-                          <p:cTn id="16" presetID="10" presetClass="entr" presetSubtype="0" fill="hold" grpId="0" nodeType="withEffect">
-                            <p:stCondLst>
-                              <p:cond delay="0"/>
-                            </p:stCondLst>
-                            <p:childTnLst>
-                              <p:set>
-                                <p:cBhvr>
-                                  <p:cTn id="17" dur="1" fill="hold">
-                                    <p:stCondLst>
-                                      <p:cond delay="0"/>
-                                    </p:stCondLst>
-                                  </p:cTn>
-                                  <p:tgtEl>
-                                    <p:spTgt spid="6"/>
-                                  </p:tgtEl>
-                                  <p:attrNameLst>
-                                    <p:attrName>style.visibility</p:attrName>
-                                  </p:attrNameLst>
-                                </p:cBhvr>
-                                <p:to>
-                                  <p:strVal val="visible"/>
-                                </p:to>
-                              </p:set>
-                              <p:animEffect transition="in" filter="fade">
-                                <p:cBhvr>
-                                  <p:cTn id="18" dur="450"/>
-                                  <p:tgtEl>
-                                    <p:spTgt spid="6"/>
-                                  </p:tgtEl>
-                                </p:cBhvr>
-                              </p:animEffect>
-                            </p:childTnLst>
-                          </p:cTn>
-                        </p:par>
-                      </p:childTnLst>
-                    </p:cTn>
-                  </p:par>
-                  <p:par>
-                    <p:cTn id="19" fill="hold" nodeType="afterEffect">
-                      <p:stCondLst>
-                        <p:cond delay="0"/>
-                      </p:stCondLst>
-                      <p:childTnLst>
-                        <p:par>
-                          <p:cTn id="20" presetID="10" presetClass="entr" presetSubtype="0" fill="hold" grpId="0" nodeType="withEffect">
-                            <p:stCondLst>
-                              <p:cond delay="0"/>
-                            </p:stCondLst>
-                            <p:childTnLst>
-                              <p:set>
-                                <p:cBhvr>
-                                  <p:cTn id="21" dur="1" fill="hold">
-                                    <p:stCondLst>
-                                      <p:cond delay="0"/>
-                                    </p:stCondLst>
-                                  </p:cTn>
-                                  <p:tgtEl>
-                                    <p:spTgt spid="7"/>
-                                  </p:tgtEl>
-                                  <p:attrNameLst>
-                                    <p:attrName>style.visibility</p:attrName>
-                                  </p:attrNameLst>
-                                </p:cBhvr>
-                                <p:to>
-                                  <p:strVal val="visible"/>
-                                </p:to>
-                              </p:set>
-                              <p:animEffect transition="in" filter="fade">
-                                <p:cBhvr>
-                                  <p:cTn id="22" dur="450"/>
-                                  <p:tgtEl>
-                                    <p:spTgt spid="7"/>
-                                  </p:tgtEl>
-                                </p:cBhvr>
-                              </p:animEffect>
-                            </p:childTnLst>
-                          </p:cTn>
-                        </p:par>
-                      </p:childTnLst>
-                    </p:cTn>
-                  </p:par>
-                  <p:par>
-                    <p:cTn id="23" fill="hold" nodeType="afterEffect">
-                      <p:stCondLst>
-                        <p:cond delay="0"/>
-                      </p:stCondLst>
-                      <p:childTnLst>
-                        <p:par>
-                          <p:cTn id="24" presetID="10" presetClass="entr" presetSubtype="0" fill="hold" grpId="0" nodeType="withEffect">
-                            <p:stCondLst>
-                              <p:cond delay="0"/>
-                            </p:stCondLst>
-                            <p:childTnLst>
-                              <p:set>
-                                <p:cBhvr>
-                                  <p:cTn id="25" dur="1" fill="hold">
-                                    <p:stCondLst>
-                                      <p:cond delay="0"/>
-                                    </p:stCondLst>
-                                  </p:cTn>
-                                  <p:tgtEl>
-                                    <p:spTgt spid="8"/>
-                                  </p:tgtEl>
-                                  <p:attrNameLst>
-                                    <p:attrName>style.visibility</p:attrName>
-                                  </p:attrNameLst>
-                                </p:cBhvr>
-                                <p:to>
-                                  <p:strVal val="visible"/>
-                                </p:to>
-                              </p:set>
-                              <p:animEffect transition="in" filter="fade">
-                                <p:cBhvr>
-                                  <p:cTn id="26" dur="450"/>
-                                  <p:tgtEl>
-                                    <p:spTgt spid="8"/>
-                                  </p:tgtEl>
-                                </p:cBhvr>
-                              </p:animEffect>
-                            </p:childTnLst>
-                          </p:cTn>
-                        </p:par>
-                      </p:childTnLst>
-                    </p:cTn>
-                  </p:par>
-                  <p:par>
-                    <p:cTn id="27" fill="hold" nodeType="afterEffect">
-                      <p:stCondLst>
-                        <p:cond delay="0"/>
-                      </p:stCondLst>
-                      <p:childTnLst>
-                        <p:par>
-                          <p:cTn id="28" presetID="10" presetClass="entr" presetSubtype="0" fill="hold" grpId="0" nodeType="withEffect">
-                            <p:stCondLst>
-                              <p:cond delay="0"/>
-                            </p:stCondLst>
-                            <p:childTnLst>
-                              <p:set>
-                                <p:cBhvr>
-                                  <p:cTn id="29" dur="1" fill="hold">
-                                    <p:stCondLst>
-                                      <p:cond delay="0"/>
-                                    </p:stCondLst>
-                                  </p:cTn>
-                                  <p:tgtEl>
-                                    <p:spTgt spid="9"/>
-                                  </p:tgtEl>
-                                  <p:attrNameLst>
-                                    <p:attrName>style.visibility</p:attrName>
-                                  </p:attrNameLst>
-                                </p:cBhvr>
-                                <p:to>
-                                  <p:strVal val="visible"/>
-                                </p:to>
-                              </p:set>
-                              <p:animEffect transition="in" filter="fade">
-                                <p:cBhvr>
-                                  <p:cTn id="30" dur="450"/>
-                                  <p:tgtEl>
-                                    <p:spTgt spid="9"/>
-                                  </p:tgtEl>
-                                </p:cBhvr>
-                              </p:animEffect>
-                            </p:childTnLst>
-                          </p:cTn>
-                        </p:par>
-                      </p:childTnLst>
-                    </p:cTn>
-                  </p:par>
-                  <p:par>
-                    <p:cTn id="31" fill="hold" nodeType="afterEffect">
-                      <p:stCondLst>
-                        <p:cond delay="0"/>
-                      </p:stCondLst>
-                      <p:childTnLst>
-                        <p:par>
-                          <p:cTn id="32" presetID="10" presetClass="entr" presetSubtype="0" fill="hold" grpId="0" nodeType="withEffect">
-                            <p:stCondLst>
-                              <p:cond delay="0"/>
-                            </p:stCondLst>
-                            <p:childTnLst>
-                              <p:set>
-                                <p:cBhvr>
-                                  <p:cTn id="33" dur="1" fill="hold">
-                                    <p:stCondLst>
-                                      <p:cond delay="0"/>
-                                    </p:stCondLst>
-                                  </p:cTn>
-                                  <p:tgtEl>
-                                    <p:spTgt spid="10"/>
-                                  </p:tgtEl>
-                                  <p:attrNameLst>
-                                    <p:attrName>style.visibility</p:attrName>
-                                  </p:attrNameLst>
-                                </p:cBhvr>
-                                <p:to>
-                                  <p:strVal val="visible"/>
-                                </p:to>
-                              </p:set>
-                              <p:animEffect transition="in" filter="fade">
-                                <p:cBhvr>
-                                  <p:cTn id="34" dur="450"/>
-                                  <p:tgtEl>
-                                    <p:spTgt spid="10"/>
-                                  </p:tgtEl>
-                                </p:cBhvr>
-                              </p:animEffect>
-                            </p:childTnLst>
-                          </p:cTn>
-                        </p:par>
-                      </p:childTnLst>
-                    </p:cTn>
-                  </p:par>
-                </p:childTnLst>
-              </p:cTn>
-              <p:prevCondLst>
-                <p:cond evt="onPrev" delay="0">
-                  <p:tgtEl>
-                    <p:sldTgt/>
-                  </p:tgtEl>
-                </p:cond>
-              </p:prevCondLst>
-              <p:nextCondLst>
-                <p:cond evt="onNext" delay="0">
-                  <p:tgtEl>
-                    <p:sldTgt/>
-                  </p:tgtEl>
-                </p:cond>
-              </p:nextCondLst>
-            </p:seq>
-          </p:childTnLst>
-        </p:cTn>
-      </p:par>
-    </p:tnLst>
-  </p:timing>
 </p:sld>
 </file>
 
@@ -3758,7 +3373,7 @@
         </p:blipFill>
         <p:spPr>
           <a:xfrm>
-            <a:off x="4940176" y="1689057"/>
+            <a:off x="4940176" y="1778000"/>
             <a:ext cx="6718132" cy="4063898"/>
           </a:xfrm>
           <a:prstGeom prst="rect">
@@ -3771,72 +3386,14 @@
   <p:clrMapOvr>
     <a:masterClrMapping/>
   </p:clrMapOvr>
-  <p:transition spd="med">
-    <p:fade/>
-  </p:transition>
   <p:timing>
     <p:tnLst>
       <p:par>
         <p:cTn id="1" dur="indefinite" restart="never" nodeType="tmRoot">
           <p:childTnLst>
-            <p:seq concurrent="1" nextAc="seek">
-              <p:cTn id="2" dur="indefinite" nodeType="mainSeq">
-                <p:childTnLst>
-                  <p:par>
-                    <p:cTn id="3" fill="hold">
-                      <p:stCondLst>
-                        <p:cond delay="0"/>
-                      </p:stCondLst>
-                      <p:childTnLst>
-                        <p:par>
-                          <p:cTn id="4" fill="hold">
-                            <p:stCondLst>
-                              <p:cond delay="0"/>
-                            </p:stCondLst>
-                            <p:childTnLst>
-                              <p:par>
-                                <p:cTn id="5" presetID="1" presetClass="mediacall" presetSubtype="0" fill="hold" nodeType="afterEffect">
-                                  <p:stCondLst>
-                                    <p:cond delay="0"/>
-                                  </p:stCondLst>
-                                  <p:childTnLst>
-                                    <p:cmd type="call" cmd="playFrom(0.0)">
-                                      <p:cBhvr>
-                                        <p:cTn id="6" dur="13560" fill="hold"/>
-                                        <p:tgtEl>
-                                          <p:spTgt spid="3"/>
-                                        </p:tgtEl>
-                                      </p:cBhvr>
-                                    </p:cmd>
-                                  </p:childTnLst>
-                                </p:cTn>
-                              </p:par>
-                            </p:childTnLst>
-                          </p:cTn>
-                        </p:par>
-                      </p:childTnLst>
-                    </p:cTn>
-                  </p:par>
-                </p:childTnLst>
-              </p:cTn>
-              <p:prevCondLst>
-                <p:cond evt="onPrev" delay="0">
-                  <p:tgtEl>
-                    <p:sldTgt/>
-                  </p:tgtEl>
-                </p:cond>
-              </p:prevCondLst>
-              <p:nextCondLst>
-                <p:cond evt="onNext" delay="0">
-                  <p:tgtEl>
-                    <p:sldTgt/>
-                  </p:tgtEl>
-                </p:cond>
-              </p:nextCondLst>
-            </p:seq>
             <p:video>
               <p:cMediaNode vol="80000">
-                <p:cTn id="7" fill="hold" display="0">
+                <p:cTn id="2" fill="hold" display="0">
                   <p:stCondLst>
                     <p:cond delay="indefinite"/>
                   </p:stCondLst>
@@ -3913,7 +3470,7 @@
         </p:blipFill>
         <p:spPr>
           <a:xfrm>
-            <a:off x="4940176" y="1689057"/>
+            <a:off x="4940176" y="1778000"/>
             <a:ext cx="6718132" cy="4063898"/>
           </a:xfrm>
           <a:prstGeom prst="rect">
@@ -3926,72 +3483,14 @@
   <p:clrMapOvr>
     <a:masterClrMapping/>
   </p:clrMapOvr>
-  <p:transition spd="med">
-    <p:fade/>
-  </p:transition>
   <p:timing>
     <p:tnLst>
       <p:par>
         <p:cTn id="1" dur="indefinite" restart="never" nodeType="tmRoot">
           <p:childTnLst>
-            <p:seq concurrent="1" nextAc="seek">
-              <p:cTn id="2" dur="indefinite" nodeType="mainSeq">
-                <p:childTnLst>
-                  <p:par>
-                    <p:cTn id="3" fill="hold">
-                      <p:stCondLst>
-                        <p:cond delay="0"/>
-                      </p:stCondLst>
-                      <p:childTnLst>
-                        <p:par>
-                          <p:cTn id="4" fill="hold">
-                            <p:stCondLst>
-                              <p:cond delay="0"/>
-                            </p:stCondLst>
-                            <p:childTnLst>
-                              <p:par>
-                                <p:cTn id="5" presetID="1" presetClass="mediacall" presetSubtype="0" fill="hold" nodeType="afterEffect">
-                                  <p:stCondLst>
-                                    <p:cond delay="0"/>
-                                  </p:stCondLst>
-                                  <p:childTnLst>
-                                    <p:cmd type="call" cmd="playFrom(0.0)">
-                                      <p:cBhvr>
-                                        <p:cTn id="6" dur="14120" fill="hold"/>
-                                        <p:tgtEl>
-                                          <p:spTgt spid="3"/>
-                                        </p:tgtEl>
-                                      </p:cBhvr>
-                                    </p:cmd>
-                                  </p:childTnLst>
-                                </p:cTn>
-                              </p:par>
-                            </p:childTnLst>
-                          </p:cTn>
-                        </p:par>
-                      </p:childTnLst>
-                    </p:cTn>
-                  </p:par>
-                </p:childTnLst>
-              </p:cTn>
-              <p:prevCondLst>
-                <p:cond evt="onPrev" delay="0">
-                  <p:tgtEl>
-                    <p:sldTgt/>
-                  </p:tgtEl>
-                </p:cond>
-              </p:prevCondLst>
-              <p:nextCondLst>
-                <p:cond evt="onNext" delay="0">
-                  <p:tgtEl>
-                    <p:sldTgt/>
-                  </p:tgtEl>
-                </p:cond>
-              </p:nextCondLst>
-            </p:seq>
             <p:video>
               <p:cMediaNode vol="80000">
-                <p:cTn id="7" fill="hold" display="0">
+                <p:cTn id="2" fill="hold" display="0">
                   <p:stCondLst>
                     <p:cond delay="indefinite"/>
                   </p:stCondLst>

</xml_diff>

<commit_message>
Fix Claude demo video crop clipping the top of the chat window
The crop rect used the pre-render bounding box (y=280) which sat ~24px
below the card's real top, clipping the "Claude" header row. Re-crop to
the measured card bounds (778,254,1060x644) so the full window is shown,
and update the PPT video placement to match.

Co-Authored-By: Claude Opus 4.8 <noreply@anthropic.com>
Claude-Session: https://claude.ai/code/session_011YSka9wdq7KrBYzbQXMRhD
</commit_message>
<xml_diff>
--- a/AGENTIC-PM-workspaces-video.pptx
+++ b/AGENTIC-PM-workspaces-video.pptx
@@ -3373,8 +3373,8 @@
         </p:blipFill>
         <p:spPr>
           <a:xfrm>
-            <a:off x="4940176" y="1778000"/>
-            <a:ext cx="6718132" cy="4063898"/>
+            <a:off x="4940900" y="1612900"/>
+            <a:ext cx="6731000" cy="4089400"/>
           </a:xfrm>
           <a:prstGeom prst="rect">
             <a:avLst/>
@@ -3470,8 +3470,8 @@
         </p:blipFill>
         <p:spPr>
           <a:xfrm>
-            <a:off x="4940176" y="1778000"/>
-            <a:ext cx="6718132" cy="4063898"/>
+            <a:off x="4940900" y="1612900"/>
+            <a:ext cx="6731000" cy="4089400"/>
           </a:xfrm>
           <a:prstGeom prst="rect">
             <a:avLst/>

</xml_diff>

<commit_message>
Frame demo card with margin; show selected skill as blue slash-command
- Fix top-clipping: recorded card is now framed with even margin on all
  sides (crop 746,222,1124x708) so the rounded window floats cleanly and
  no longer reads as cut off at the top; leading slide-transition frames
  trimmed and entrance rise disabled for a static, crisp card.
- Composer chip now shows the selected skill as a blue monospace
  slash-command (e.g. /market-research, /cim-screener).
- Rebuild combined MP4 and PPT embedded clips/placement to match.

Co-Authored-By: Claude Opus 4.8 <noreply@anthropic.com>
Claude-Session: https://claude.ai/code/session_011YSka9wdq7KrBYzbQXMRhD
</commit_message>
<xml_diff>
--- a/AGENTIC-PM-workspaces-video.pptx
+++ b/AGENTIC-PM-workspaces-video.pptx
@@ -3373,8 +3373,8 @@
         </p:blipFill>
         <p:spPr>
           <a:xfrm>
-            <a:off x="4940900" y="1612900"/>
-            <a:ext cx="6731000" cy="4089400"/>
+            <a:off x="4737100" y="1409700"/>
+            <a:ext cx="7137400" cy="4495800"/>
           </a:xfrm>
           <a:prstGeom prst="rect">
             <a:avLst/>
@@ -3470,8 +3470,8 @@
         </p:blipFill>
         <p:spPr>
           <a:xfrm>
-            <a:off x="4940900" y="1612900"/>
-            <a:ext cx="6731000" cy="4089400"/>
+            <a:off x="4737100" y="1409700"/>
+            <a:ext cx="7137400" cy="4495800"/>
           </a:xfrm>
           <a:prstGeom prst="rect">
             <a:avLst/>

</xml_diff>